<commit_message>
Presentación: comando python main.py --demo y URL real del repositorio
Láminas 5 y 10 y sus notas; diseño sin cambios.
</commit_message>
<xml_diff>
--- a/docs/presentacion_mlops_infartos.pptx
+++ b/docs/presentacion_mlops_infartos.pptx
@@ -415,7 +415,7 @@
             <a:pPr/>
             <a:r>
               <a:rPr lang="es-419" dirty="0"/>
-              <a:t>Para cerrar, este repositorio integra las diez unidades del curso, desde el repositorio base y el código modular hasta el monitoreo y el orquestador main.py. Todo se puede ejecutar de punta a punta en GitHub Codespaces: se abre el Codespace y se corre python main.py, y el README tiene la guía completa. Como próximos pasos proponemos calibrar las probabilidades del modelo, usar edad y glucosa como variables continuas y configurar un remoto de DVC compartido. Gracias, quedo atento a sus preguntas.</a:t>
+              <a:t>Para cerrar, este repositorio integra las diez unidades del curso, desde el repositorio base y el código modular hasta el monitoreo y el orquestador main.py. Todo se puede ejecutar de punta a punta en GitHub Codespaces: se abre el Codespace y se corre python main.py con la opción demo, que deja todo funcionando, y el README del repositorio Mlops-proyectofinal tiene la guía completa. Como próximos pasos proponemos calibrar las probabilidades del modelo, usar edad y glucosa como variables continuas y configurar un remoto de DVC compartido. Gracias, quedo atento a sus preguntas.</a:t>
             </a:r>
           </a:p>
         </p:txBody>
@@ -655,7 +655,7 @@
             <a:pPr/>
             <a:r>
               <a:rPr lang="es-419" dirty="0"/>
-              <a:t>Lo que convierte esto en MLOps es el pipeline. Siete etapas encadenadas corren con un solo comando, python main.py: ingesta y validación de columnas, preprocesamiento, split estratificado, once tests de datos, tuning con MLflow, evaluación y detección de drift. La sexta etapa es el quality gate: si el modelo no cumple los umbrales, main.py se detiene y no se despliega nada. Después del pipeline, el modelo se sirve con FastAPI, se empaqueta en Docker y todo el flujo corre en GitHub Actions.</a:t>
+              <a:t>Lo que convierte esto en MLOps es el pipeline. Siete etapas encadenadas corren con un solo comando, python main.py: ingesta y validación de columnas, preprocesamiento, split estratificado, once tests de datos, tuning con MLflow, evaluación y detección de drift. La sexta etapa es el quality gate: si el modelo no cumple los umbrales, main.py se detiene y no se despliega nada. Después del pipeline, el modelo se sirve con FastAPI, se empaqueta en Docker y todo el flujo corre en GitHub Actions. Para la demostración, python main.py con la opción demo agrega el drift simulado, construye y prueba la imagen Docker y deja arriba la interfaz de MLflow y la API.</a:t>
             </a:r>
           </a:p>
         </p:txBody>
@@ -3808,7 +3808,7 @@
           <p:spPr>
             <a:xfrm>
               <a:off x="906780" y="5499100"/>
-              <a:ext cx="3809292" cy="293370"/>
+              <a:ext cx="4586723" cy="293370"/>
             </a:xfrm>
             <a:prstGeom prst="rect">
               <a:avLst/>
@@ -3845,7 +3845,7 @@
                   <a:ea typeface="Consolas"/>
                   <a:cs typeface="Consolas"/>
                 </a:rPr>
-                <a:t>python main.py</a:t>
+                <a:t>python main.py --demo</a:t>
               </a:r>
             </a:p>
           </p:txBody>
@@ -3859,7 +3859,7 @@
           <p:spPr>
             <a:xfrm>
               <a:off x="908304" y="5829300"/>
-              <a:ext cx="4294890" cy="234696"/>
+              <a:ext cx="4755630" cy="234696"/>
             </a:xfrm>
             <a:prstGeom prst="rect">
               <a:avLst/>
@@ -3885,7 +3885,7 @@
                   <a:ea typeface="+mn-ea"/>
                   <a:cs typeface="+mn-cs"/>
                 </a:rPr>
-                <a:t>Repositorio mlops-infartos · README con la guía completa</a:t>
+                <a:t>github.com/hangelo83/Mlops-proyectofinal · README con la guía</a:t>
               </a:r>
             </a:p>
           </p:txBody>
@@ -8699,10 +8699,10 @@
         </p:nvGrpSpPr>
         <p:grpSpPr>
           <a:xfrm>
-            <a:off x="609600" y="5600700"/>
-            <a:ext cx="10972800" cy="533400"/>
-            <a:chOff x="609600" y="5600700"/>
-            <a:chExt cx="10972800" cy="533400"/>
+            <a:off x="609600" y="5524500"/>
+            <a:ext cx="10972800" cy="704850"/>
+            <a:chOff x="609600" y="5524500"/>
+            <a:chExt cx="10972800" cy="704850"/>
           </a:xfrm>
         </p:grpSpPr>
         <p:sp>
@@ -8713,8 +8713,8 @@
           </p:nvSpPr>
           <p:spPr>
             <a:xfrm>
-              <a:off x="609600" y="5600700"/>
-              <a:ext cx="10972800" cy="533400"/>
+              <a:off x="609600" y="5524500"/>
+              <a:ext cx="10972800" cy="704850"/>
             </a:xfrm>
             <a:prstGeom prst="rect">
               <a:avLst/>
@@ -8735,8 +8735,8 @@
           </p:nvSpPr>
           <p:spPr>
             <a:xfrm>
-              <a:off x="831342" y="5759450"/>
-              <a:ext cx="8409965" cy="264033"/>
+              <a:off x="831342" y="5600700"/>
+              <a:ext cx="8217598" cy="511683"/>
             </a:xfrm>
             <a:prstGeom prst="rect">
               <a:avLst/>
@@ -8752,7 +8752,11 @@
             </a:bodyPr>
             <a:lstStyle/>
             <a:p>
-              <a:pPr algn="l"/>
+              <a:pPr algn="l">
+                <a:lnSpc>
+                  <a:spcPts val="1950"/>
+                </a:lnSpc>
+              </a:pPr>
               <a:r>
                 <a:rPr lang="es-419" sz="1350" dirty="0">
                   <a:solidFill>
@@ -8762,7 +8766,7 @@
                   <a:ea typeface="Consolas"/>
                   <a:cs typeface="Consolas"/>
                 </a:rPr>
-                <a:t>$ python main.py</a:t>
+                <a:t xml:space="preserve">$ python main.py          </a:t>
               </a:r>
               <a:r>
                 <a:rPr lang="es-419" sz="1350" dirty="0">
@@ -8773,7 +8777,39 @@
                   <a:ea typeface="Consolas"/>
                   <a:cs typeface="Consolas"/>
                 </a:rPr>
-                <a:t xml:space="preserve"> # las 7 etapas en ~1 minuto, con log y resumen de métricas al final</a:t>
+                <a:t># las 7 etapas en ~1-2 minutos, con log y resumen de métricas</a:t>
+              </a:r>
+              <a:br>
+                <a:rPr lang="es-419" sz="1350" dirty="0">
+                  <a:solidFill>
+                    <a:srgbClr val="9FB2C8"/>
+                  </a:solidFill>
+                  <a:latin typeface="Consolas"/>
+                  <a:ea typeface="Consolas"/>
+                  <a:cs typeface="Consolas"/>
+                </a:rPr>
+              </a:br>
+              <a:r>
+                <a:rPr lang="es-419" sz="1350" dirty="0">
+                  <a:solidFill>
+                    <a:srgbClr val="FFFFFF"/>
+                  </a:solidFill>
+                  <a:latin typeface="Consolas"/>
+                  <a:ea typeface="Consolas"/>
+                  <a:cs typeface="Consolas"/>
+                </a:rPr>
+                <a:t>$ python main.py --demo</a:t>
+              </a:r>
+              <a:r>
+                <a:rPr lang="es-419" sz="1350" dirty="0">
+                  <a:solidFill>
+                    <a:srgbClr val="9FB2C8"/>
+                  </a:solidFill>
+                  <a:latin typeface="Consolas"/>
+                  <a:ea typeface="Consolas"/>
+                  <a:cs typeface="Consolas"/>
+                </a:rPr>
+                <a:t xml:space="preserve">   # + drift simulado, Docker, MLflow UI y API arriba</a:t>
               </a:r>
             </a:p>
           </p:txBody>

</xml_diff>

<commit_message>
Presentación: notas de láminas 6 y 7 con fairness y línea base
Láminas sin cambios de diseño.
</commit_message>
<xml_diff>
--- a/docs/presentacion_mlops_infartos.pptx
+++ b/docs/presentacion_mlops_infartos.pptx
@@ -715,7 +715,7 @@
             <a:pPr/>
             <a:r>
               <a:rPr lang="es-419" dirty="0"/>
-              <a:t>Este es el punto de control más importante. El quality gate exige AUC de al menos 0,80 y recall de al menos 0,70, y el modelo los supera con 0,828 y 0,815. El F1 queda solo como piso, porque con 1,8% de positivos el umbral de 0,70 del template de la Unidad 10 es inalcanzable. La precisión de 0,053 significa que por cada infarto detectado entran unos 18 asegurados sanos al programa, un costo aceptable si se compara un chequeo con un infarto no atendido. Al aprobar, el modelo pasa automáticamente a Production.</a:t>
+              <a:t>Este es el punto de control más importante. El quality gate exige AUC de al menos 0,80 y recall de al menos 0,70, y el modelo los supera con 0,828 y 0,815. El F1 queda solo como piso, porque con 1,8% de positivos el umbral de 0,70 del template de la Unidad 10 es inalcanzable. La precisión de 0,053 significa que por cada infarto detectado entran unos 18 asegurados sanos al programa, un costo aceptable si se compara un chequeo con un infarto no atendido. Al aprobar, el modelo pasa automáticamente a Production. Además auditamos fairness con variables que el modelo no usa: marca a una proporción pareja de cada grupo, entre 27 y 29%, pero el recall es 0,85 en hombres y 0,79 en mujeres, y 0,88 en zona rural frente a 0,75 en urbana. Con unos 80 infartos por grupo puede ser ruido, así que queda registrado en MLflow como riesgo a vigilar.</a:t>
             </a:r>
           </a:p>
         </p:txBody>
@@ -775,7 +775,7 @@
             <a:pPr/>
             <a:r>
               <a:rPr lang="es-419" dirty="0"/>
-              <a:t>Cada experimento queda registrado. Corrimos dos búsquedas de hiperparámetros en MLflow: GridSearchCV con 18 combinaciones y RandomizedSearchCV con 20, y ganó la segunda por validación cruzada, con un F1 de 0,096 frente a 0,092. El mejor run se registra como InfartosRiskModel, queda en Staging y solo pasa a Production si aprueba el gate; si falla, la versión anterior sigue en servicio, y cada versión lleva tags de método, balanceo, AUC y recall. En paralelo, DVC versiona los datos y el modelo sin subirlos a Git: dvc.yaml declara las siete etapas y dvc.lock guarda el hash de cada salida.</a:t>
+              <a:t>Cada experimento queda registrado. Corrimos dos búsquedas de hiperparámetros en MLflow: GridSearchCV con 18 combinaciones y RandomizedSearchCV con 20, y ganó la segunda por validación cruzada, con un F1 de 0,096 frente a 0,092. Ambos se compararon con una línea base, la Regresión Logística de la Unidad 2, y el resultado es honesto: empata con el Random Forest, con un AUC de 0,825 frente a 0,828 en test. Con siete variables en tramos el techo lo ponen los datos y no el algoritmo, por eso el próximo paso son variables continuas y no más tuning. El mejor run se registra como InfartosRiskModel, queda en Staging y solo pasa a Production si aprueba el gate; si falla, la versión anterior sigue en servicio, y cada versión lleva tags de método, balanceo, AUC y recall. En paralelo, DVC versiona los datos y el modelo sin subirlos a Git: dvc.yaml declara las siete etapas y dvc.lock guarda el hash de cada salida.</a:t>
             </a:r>
           </a:p>
         </p:txBody>

</xml_diff>

<commit_message>
Presentación: lámina 7 con la línea base como tercera tarjeta
</commit_message>
<xml_diff>
--- a/docs/presentacion_mlops_infartos.pptx
+++ b/docs/presentacion_mlops_infartos.pptx
@@ -10236,16 +10236,16 @@
       </p:grpSp>
       <p:grpSp>
         <p:nvGrpSpPr>
-          <p:cNvPr id="19" name="runs-tuning"/>
+          <p:cNvPr id="21" name="runs-tuning"/>
           <p:cNvGrpSpPr/>
           <p:nvPr/>
         </p:nvGrpSpPr>
         <p:grpSpPr>
           <a:xfrm>
             <a:off x="603885" y="2184400"/>
-            <a:ext cx="4958715" cy="2882900"/>
+            <a:ext cx="4958715" cy="3035300"/>
             <a:chOff x="603885" y="2184400"/>
-            <a:chExt cx="4958715" cy="2882900"/>
+            <a:chExt cx="4958715" cy="3035300"/>
           </a:xfrm>
         </p:grpSpPr>
         <p:sp>
@@ -10257,7 +10257,7 @@
           <p:spPr>
             <a:xfrm>
               <a:off x="603885" y="2184400"/>
-              <a:ext cx="2781491" cy="220028"/>
+              <a:ext cx="3525400" cy="220028"/>
             </a:xfrm>
             <a:prstGeom prst="rect">
               <a:avLst/>
@@ -10283,7 +10283,7 @@
                   <a:ea typeface="+mn-ea"/>
                   <a:cs typeface="+mn-cs"/>
                 </a:rPr>
-                <a:t>DOS RUNS DE TUNING EN MLFLOW</a:t>
+                <a:t>LÍNEA BASE Y DOS RUNS DE TUNING · CV F1</a:t>
               </a:r>
             </a:p>
           </p:txBody>
@@ -10297,7 +10297,7 @@
           <p:spPr>
             <a:xfrm>
               <a:off x="609600" y="2476500"/>
-              <a:ext cx="4953000" cy="1219200"/>
+              <a:ext cx="4953000" cy="838200"/>
             </a:xfrm>
             <a:prstGeom prst="rect">
               <a:avLst/>
@@ -10318,8 +10318,8 @@
           </p:nvSpPr>
           <p:spPr>
             <a:xfrm>
-              <a:off x="831342" y="2673350"/>
-              <a:ext cx="1235812" cy="264033"/>
+              <a:off x="831342" y="2654300"/>
+              <a:ext cx="1824228" cy="264033"/>
             </a:xfrm>
             <a:prstGeom prst="rect">
               <a:avLst/>
@@ -10345,7 +10345,7 @@
                   <a:ea typeface="Consolas"/>
                   <a:cs typeface="Consolas"/>
                 </a:rPr>
-                <a:t>GridSearchCV</a:t>
+                <a:t>LogisticRegression</a:t>
               </a:r>
             </a:p>
           </p:txBody>
@@ -10359,7 +10359,7 @@
           <p:spPr>
             <a:xfrm>
               <a:off x="832104" y="2933700"/>
-              <a:ext cx="1974467" cy="234696"/>
+              <a:ext cx="2744565" cy="234696"/>
             </a:xfrm>
             <a:prstGeom prst="rect">
               <a:avLst/>
@@ -10385,7 +10385,7 @@
                   <a:ea typeface="+mn-ea"/>
                   <a:cs typeface="+mn-cs"/>
                 </a:rPr>
-                <a:t>18 combinaciones × 5 folds</a:t>
+                <a:t>Línea base de la Unidad 2 · sin tuning</a:t>
               </a:r>
             </a:p>
           </p:txBody>
@@ -10398,8 +10398,70 @@
           </p:nvSpPr>
           <p:spPr>
             <a:xfrm>
-              <a:off x="832104" y="3314700"/>
-              <a:ext cx="495922" cy="234696"/>
+              <a:off x="4615842" y="2755900"/>
+              <a:ext cx="728826" cy="410718"/>
+            </a:xfrm>
+            <a:prstGeom prst="rect">
+              <a:avLst/>
+            </a:prstGeom>
+            <a:noFill/>
+            <a:ln>
+              <a:noFill/>
+            </a:ln>
+          </p:spPr>
+          <p:txBody>
+            <a:bodyPr wrap="none" lIns="0" tIns="0" rIns="0" bIns="0" anchor="t" anchorCtr="0">
+              <a:spAutoFit/>
+            </a:bodyPr>
+            <a:lstStyle/>
+            <a:p>
+              <a:pPr algn="r"/>
+              <a:r>
+                <a:rPr lang="es-419" sz="2100" b="1" dirty="0">
+                  <a:solidFill>
+                    <a:schemeClr val="accent1"/>
+                  </a:solidFill>
+                  <a:latin typeface="+mn-lt"/>
+                  <a:ea typeface="+mn-ea"/>
+                  <a:cs typeface="+mn-cs"/>
+                </a:rPr>
+                <a:t>0,096</a:t>
+              </a:r>
+            </a:p>
+          </p:txBody>
+        </p:sp>
+        <p:sp>
+          <p:nvSpPr>
+            <p:cNvPr id="11" name="Rectangle 11"/>
+            <p:cNvSpPr/>
+            <p:nvPr/>
+          </p:nvSpPr>
+          <p:spPr>
+            <a:xfrm>
+              <a:off x="609600" y="3429000"/>
+              <a:ext cx="4953000" cy="838200"/>
+            </a:xfrm>
+            <a:prstGeom prst="rect">
+              <a:avLst/>
+            </a:prstGeom>
+            <a:solidFill>
+              <a:schemeClr val="lt2"/>
+            </a:solidFill>
+            <a:ln>
+              <a:noFill/>
+            </a:ln>
+          </p:spPr>
+        </p:sp>
+        <p:sp>
+          <p:nvSpPr>
+            <p:cNvPr id="12" name="TextBox 12"/>
+            <p:cNvSpPr txBox="1"/>
+            <p:nvPr/>
+          </p:nvSpPr>
+          <p:spPr>
+            <a:xfrm>
+              <a:off x="831342" y="3606800"/>
+              <a:ext cx="1235812" cy="264033"/>
             </a:xfrm>
             <a:prstGeom prst="rect">
               <a:avLst/>
@@ -10417,28 +10479,68 @@
             <a:p>
               <a:pPr algn="l"/>
               <a:r>
-                <a:rPr lang="es-419" sz="1200" dirty="0">
-                  <a:solidFill>
-                    <a:schemeClr val="accent5"/>
-                  </a:solidFill>
-                  <a:latin typeface="+mn-lt"/>
-                  <a:ea typeface="+mn-ea"/>
-                  <a:cs typeface="+mn-cs"/>
-                </a:rPr>
-                <a:t>CV F1</a:t>
+                <a:rPr lang="es-419" sz="1350" b="1" dirty="0">
+                  <a:solidFill>
+                    <a:schemeClr val="accent1"/>
+                  </a:solidFill>
+                  <a:latin typeface="Consolas"/>
+                  <a:ea typeface="Consolas"/>
+                  <a:cs typeface="Consolas"/>
+                </a:rPr>
+                <a:t>GridSearchCV</a:t>
               </a:r>
             </a:p>
           </p:txBody>
         </p:sp>
         <p:sp>
           <p:nvSpPr>
-            <p:cNvPr id="11" name="TextBox 11"/>
+            <p:cNvPr id="13" name="TextBox 13"/>
             <p:cNvSpPr txBox="1"/>
             <p:nvPr/>
           </p:nvSpPr>
           <p:spPr>
             <a:xfrm>
-              <a:off x="4615842" y="3232150"/>
+              <a:off x="832104" y="3886200"/>
+              <a:ext cx="3243492" cy="234696"/>
+            </a:xfrm>
+            <a:prstGeom prst="rect">
+              <a:avLst/>
+            </a:prstGeom>
+            <a:noFill/>
+            <a:ln>
+              <a:noFill/>
+            </a:ln>
+          </p:spPr>
+          <p:txBody>
+            <a:bodyPr wrap="none" lIns="0" tIns="0" rIns="0" bIns="0" anchor="t" anchorCtr="0">
+              <a:spAutoFit/>
+            </a:bodyPr>
+            <a:lstStyle/>
+            <a:p>
+              <a:pPr algn="l"/>
+              <a:r>
+                <a:rPr lang="es-419" sz="1200" dirty="0">
+                  <a:solidFill>
+                    <a:schemeClr val="accent5"/>
+                  </a:solidFill>
+                  <a:latin typeface="+mn-lt"/>
+                  <a:ea typeface="+mn-ea"/>
+                  <a:cs typeface="+mn-cs"/>
+                </a:rPr>
+                <a:t>Random Forest · 18 combinaciones × 5 folds</a:t>
+              </a:r>
+            </a:p>
+          </p:txBody>
+        </p:sp>
+        <p:sp>
+          <p:nvSpPr>
+            <p:cNvPr id="14" name="TextBox 14"/>
+            <p:cNvSpPr txBox="1"/>
+            <p:nvPr/>
+          </p:nvSpPr>
+          <p:spPr>
+            <a:xfrm>
+              <a:off x="4615842" y="3708400"/>
               <a:ext cx="728826" cy="410718"/>
             </a:xfrm>
             <a:prstGeom prst="rect">
@@ -10472,14 +10574,14 @@
         </p:sp>
         <p:sp>
           <p:nvSpPr>
-            <p:cNvPr id="12" name="Rectangle 12"/>
+            <p:cNvPr id="15" name="Rectangle 15"/>
             <p:cNvSpPr/>
             <p:nvPr/>
           </p:nvSpPr>
           <p:spPr>
             <a:xfrm>
-              <a:off x="609600" y="3848100"/>
-              <a:ext cx="4953000" cy="1219200"/>
+              <a:off x="609600" y="4381500"/>
+              <a:ext cx="4953000" cy="838200"/>
             </a:xfrm>
             <a:prstGeom prst="rect">
               <a:avLst/>
@@ -10494,14 +10596,14 @@
         </p:sp>
         <p:sp>
           <p:nvSpPr>
-            <p:cNvPr id="13" name="Rectangle 13"/>
+            <p:cNvPr id="16" name="Rectangle 16"/>
             <p:cNvSpPr/>
             <p:nvPr/>
           </p:nvSpPr>
           <p:spPr>
             <a:xfrm>
-              <a:off x="609600" y="3848100"/>
-              <a:ext cx="57150" cy="1219200"/>
+              <a:off x="609600" y="4381500"/>
+              <a:ext cx="57150" cy="838200"/>
             </a:xfrm>
             <a:prstGeom prst="rect">
               <a:avLst/>
@@ -10516,13 +10618,13 @@
         </p:sp>
         <p:sp>
           <p:nvSpPr>
-            <p:cNvPr id="14" name="TextBox 14"/>
+            <p:cNvPr id="17" name="TextBox 17"/>
             <p:cNvSpPr txBox="1"/>
             <p:nvPr/>
           </p:nvSpPr>
           <p:spPr>
             <a:xfrm>
-              <a:off x="831342" y="4044950"/>
+              <a:off x="831342" y="4559300"/>
               <a:ext cx="1835544" cy="264033"/>
             </a:xfrm>
             <a:prstGeom prst="rect">
@@ -10556,14 +10658,14 @@
         </p:sp>
         <p:sp>
           <p:nvSpPr>
-            <p:cNvPr id="15" name="TextBox 15"/>
+            <p:cNvPr id="18" name="TextBox 18"/>
             <p:cNvSpPr txBox="1"/>
             <p:nvPr/>
           </p:nvSpPr>
           <p:spPr>
             <a:xfrm>
-              <a:off x="832104" y="4305300"/>
-              <a:ext cx="3037717" cy="234696"/>
+              <a:off x="832104" y="4838700"/>
+              <a:ext cx="3092601" cy="234696"/>
             </a:xfrm>
             <a:prstGeom prst="rect">
               <a:avLst/>
@@ -10589,20 +10691,20 @@
                   <a:ea typeface="+mn-ea"/>
                   <a:cs typeface="+mn-cs"/>
                 </a:rPr>
-                <a:t>20 combinaciones × 5 folds · gana por CV</a:t>
+                <a:t>Random Forest · 20 comb. · en Production</a:t>
               </a:r>
             </a:p>
           </p:txBody>
         </p:sp>
         <p:sp>
           <p:nvSpPr>
-            <p:cNvPr id="16" name="Freeform 16"/>
+            <p:cNvPr id="19" name="Freeform 19"/>
             <p:cNvSpPr/>
             <p:nvPr/>
           </p:nvSpPr>
           <p:spPr>
             <a:xfrm>
-              <a:off x="881695" y="4694743"/>
+              <a:off x="4158295" y="4732843"/>
               <a:ext cx="190951" cy="135515"/>
             </a:xfrm>
             <a:custGeom>
@@ -10666,53 +10768,13 @@
         </p:sp>
         <p:sp>
           <p:nvSpPr>
-            <p:cNvPr id="17" name="TextBox 17"/>
+            <p:cNvPr id="20" name="TextBox 20"/>
             <p:cNvSpPr txBox="1"/>
             <p:nvPr/>
           </p:nvSpPr>
           <p:spPr>
             <a:xfrm>
-              <a:off x="1175004" y="4686300"/>
-              <a:ext cx="495922" cy="234696"/>
-            </a:xfrm>
-            <a:prstGeom prst="rect">
-              <a:avLst/>
-            </a:prstGeom>
-            <a:noFill/>
-            <a:ln>
-              <a:noFill/>
-            </a:ln>
-          </p:spPr>
-          <p:txBody>
-            <a:bodyPr wrap="none" lIns="0" tIns="0" rIns="0" bIns="0" anchor="t" anchorCtr="0">
-              <a:spAutoFit/>
-            </a:bodyPr>
-            <a:lstStyle/>
-            <a:p>
-              <a:pPr algn="l"/>
-              <a:r>
-                <a:rPr lang="es-419" sz="1200" b="1" dirty="0">
-                  <a:solidFill>
-                    <a:schemeClr val="accent1"/>
-                  </a:solidFill>
-                  <a:latin typeface="+mn-lt"/>
-                  <a:ea typeface="+mn-ea"/>
-                  <a:cs typeface="+mn-cs"/>
-                </a:rPr>
-                <a:t>CV F1</a:t>
-              </a:r>
-            </a:p>
-          </p:txBody>
-        </p:sp>
-        <p:sp>
-          <p:nvSpPr>
-            <p:cNvPr id="18" name="TextBox 18"/>
-            <p:cNvSpPr txBox="1"/>
-            <p:nvPr/>
-          </p:nvSpPr>
-          <p:spPr>
-            <a:xfrm>
-              <a:off x="4615842" y="4603750"/>
+              <a:off x="4615842" y="4660900"/>
               <a:ext cx="728826" cy="410718"/>
             </a:xfrm>
             <a:prstGeom prst="rect">
@@ -10747,7 +10809,7 @@
       </p:grpSp>
       <p:grpSp>
         <p:nvGrpSpPr>
-          <p:cNvPr id="37" name="ciclo-registry"/>
+          <p:cNvPr id="39" name="ciclo-registry"/>
           <p:cNvGrpSpPr/>
           <p:nvPr/>
         </p:nvGrpSpPr>
@@ -10761,7 +10823,7 @@
         </p:grpSpPr>
         <p:sp>
           <p:nvSpPr>
-            <p:cNvPr id="20" name="TextBox 20"/>
+            <p:cNvPr id="22" name="TextBox 22"/>
             <p:cNvSpPr txBox="1"/>
             <p:nvPr/>
           </p:nvSpPr>
@@ -10801,7 +10863,7 @@
         </p:sp>
         <p:sp>
           <p:nvSpPr>
-            <p:cNvPr id="21" name="Rectangle 21"/>
+            <p:cNvPr id="23" name="Rectangle 23"/>
             <p:cNvSpPr/>
             <p:nvPr/>
           </p:nvSpPr>
@@ -10823,7 +10885,7 @@
         </p:sp>
         <p:sp>
           <p:nvSpPr>
-            <p:cNvPr id="22" name="TextBox 22"/>
+            <p:cNvPr id="24" name="TextBox 24"/>
             <p:cNvSpPr txBox="1"/>
             <p:nvPr/>
           </p:nvSpPr>
@@ -10863,7 +10925,7 @@
         </p:sp>
         <p:sp>
           <p:nvSpPr>
-            <p:cNvPr id="23" name="Line 23"/>
+            <p:cNvPr id="25" name="Line 25"/>
             <p:cNvSpPr/>
             <p:nvPr/>
           </p:nvSpPr>
@@ -10886,7 +10948,7 @@
         </p:sp>
         <p:sp>
           <p:nvSpPr>
-            <p:cNvPr id="24" name="Rectangle 24"/>
+            <p:cNvPr id="26" name="Rectangle 26"/>
             <p:cNvSpPr/>
             <p:nvPr/>
           </p:nvSpPr>
@@ -10908,7 +10970,7 @@
         </p:sp>
         <p:sp>
           <p:nvSpPr>
-            <p:cNvPr id="25" name="TextBox 25"/>
+            <p:cNvPr id="27" name="TextBox 27"/>
             <p:cNvSpPr txBox="1"/>
             <p:nvPr/>
           </p:nvSpPr>
@@ -10948,7 +11010,7 @@
         </p:sp>
         <p:sp>
           <p:nvSpPr>
-            <p:cNvPr id="26" name="Line 26"/>
+            <p:cNvPr id="28" name="Line 28"/>
             <p:cNvSpPr/>
             <p:nvPr/>
           </p:nvSpPr>
@@ -10971,7 +11033,7 @@
         </p:sp>
         <p:sp>
           <p:nvSpPr>
-            <p:cNvPr id="27" name="Freeform 27"/>
+            <p:cNvPr id="29" name="Freeform 29"/>
             <p:cNvSpPr/>
             <p:nvPr/>
           </p:nvSpPr>
@@ -10993,7 +11055,7 @@
         </p:sp>
         <p:sp>
           <p:nvSpPr>
-            <p:cNvPr id="28" name="TextBox 28"/>
+            <p:cNvPr id="30" name="TextBox 30"/>
             <p:cNvSpPr txBox="1"/>
             <p:nvPr/>
           </p:nvSpPr>
@@ -11033,7 +11095,7 @@
         </p:sp>
         <p:sp>
           <p:nvSpPr>
-            <p:cNvPr id="29" name="Line 29"/>
+            <p:cNvPr id="31" name="Line 31"/>
             <p:cNvSpPr/>
             <p:nvPr/>
           </p:nvSpPr>
@@ -11056,7 +11118,7 @@
         </p:sp>
         <p:sp>
           <p:nvSpPr>
-            <p:cNvPr id="30" name="Rectangle 30"/>
+            <p:cNvPr id="32" name="Rectangle 32"/>
             <p:cNvSpPr/>
             <p:nvPr/>
           </p:nvSpPr>
@@ -11078,7 +11140,7 @@
         </p:sp>
         <p:sp>
           <p:nvSpPr>
-            <p:cNvPr id="31" name="TextBox 31"/>
+            <p:cNvPr id="33" name="TextBox 33"/>
             <p:cNvSpPr txBox="1"/>
             <p:nvPr/>
           </p:nvSpPr>
@@ -11118,7 +11180,7 @@
         </p:sp>
         <p:grpSp>
           <p:nvGrpSpPr>
-            <p:cNvPr id="36" name="Group 36"/>
+            <p:cNvPr id="38" name="Group 38"/>
             <p:cNvGrpSpPr/>
             <p:nvPr/>
           </p:nvGrpSpPr>
@@ -11132,7 +11194,7 @@
           </p:grpSpPr>
           <p:sp>
             <p:nvSpPr>
-              <p:cNvPr id="32" name="TextBox 32"/>
+              <p:cNvPr id="34" name="TextBox 34"/>
               <p:cNvSpPr txBox="1"/>
               <p:nvPr/>
             </p:nvSpPr>
@@ -11172,7 +11234,7 @@
           </p:sp>
           <p:sp>
             <p:nvSpPr>
-              <p:cNvPr id="33" name="TextBox 33"/>
+              <p:cNvPr id="35" name="TextBox 35"/>
               <p:cNvSpPr txBox="1"/>
               <p:nvPr/>
             </p:nvSpPr>
@@ -11212,7 +11274,7 @@
           </p:sp>
           <p:sp>
             <p:nvSpPr>
-              <p:cNvPr id="34" name="TextBox 34"/>
+              <p:cNvPr id="36" name="TextBox 36"/>
               <p:cNvSpPr txBox="1"/>
               <p:nvPr/>
             </p:nvSpPr>
@@ -11252,7 +11314,7 @@
           </p:sp>
           <p:sp>
             <p:nvSpPr>
-              <p:cNvPr id="35" name="TextBox 35"/>
+              <p:cNvPr id="37" name="TextBox 37"/>
               <p:cNvSpPr txBox="1"/>
               <p:nvPr/>
             </p:nvSpPr>
@@ -11294,7 +11356,7 @@
       </p:grpSp>
       <p:grpSp>
         <p:nvGrpSpPr>
-          <p:cNvPr id="45" name="dvc"/>
+          <p:cNvPr id="47" name="dvc"/>
           <p:cNvGrpSpPr/>
           <p:nvPr/>
         </p:nvGrpSpPr>
@@ -11308,7 +11370,7 @@
         </p:grpSpPr>
         <p:sp>
           <p:nvSpPr>
-            <p:cNvPr id="38" name="Rectangle 38"/>
+            <p:cNvPr id="40" name="Rectangle 40"/>
             <p:cNvSpPr/>
             <p:nvPr/>
           </p:nvSpPr>
@@ -11330,7 +11392,7 @@
         </p:sp>
         <p:grpSp>
           <p:nvGrpSpPr>
-            <p:cNvPr id="42" name="Group 42"/>
+            <p:cNvPr id="44" name="Group 44"/>
             <p:cNvGrpSpPr/>
             <p:nvPr/>
           </p:nvGrpSpPr>
@@ -11344,7 +11406,7 @@
           </p:grpSpPr>
           <p:sp>
             <p:nvSpPr>
-              <p:cNvPr id="39" name="Freeform 39"/>
+              <p:cNvPr id="41" name="Freeform 41"/>
               <p:cNvSpPr/>
               <p:nvPr/>
             </p:nvSpPr>
@@ -11404,7 +11466,7 @@
           </p:sp>
           <p:sp>
             <p:nvSpPr>
-              <p:cNvPr id="40" name="Freeform 40"/>
+              <p:cNvPr id="42" name="Freeform 42"/>
               <p:cNvSpPr/>
               <p:nvPr/>
             </p:nvSpPr>
@@ -11467,7 +11529,7 @@
           </p:sp>
           <p:sp>
             <p:nvSpPr>
-              <p:cNvPr id="41" name="Freeform 41"/>
+              <p:cNvPr id="43" name="Freeform 43"/>
               <p:cNvSpPr/>
               <p:nvPr/>
             </p:nvSpPr>
@@ -11589,7 +11651,7 @@
         </p:grpSp>
         <p:sp>
           <p:nvSpPr>
-            <p:cNvPr id="43" name="TextBox 43"/>
+            <p:cNvPr id="45" name="TextBox 45"/>
             <p:cNvSpPr txBox="1"/>
             <p:nvPr/>
           </p:nvSpPr>
@@ -11629,7 +11691,7 @@
         </p:sp>
         <p:sp>
           <p:nvSpPr>
-            <p:cNvPr id="44" name="TextBox 44"/>
+            <p:cNvPr id="46" name="TextBox 46"/>
             <p:cNvSpPr txBox="1"/>
             <p:nvPr/>
           </p:nvSpPr>
@@ -11670,7 +11732,7 @@
       </p:grpSp>
       <p:grpSp>
         <p:nvGrpSpPr>
-          <p:cNvPr id="48" name="footer"/>
+          <p:cNvPr id="50" name="footer"/>
           <p:cNvGrpSpPr/>
           <p:nvPr/>
         </p:nvGrpSpPr>
@@ -11684,7 +11746,7 @@
         </p:grpSpPr>
         <p:sp>
           <p:nvSpPr>
-            <p:cNvPr id="46" name="TextBox 46"/>
+            <p:cNvPr id="48" name="TextBox 48"/>
             <p:cNvSpPr txBox="1"/>
             <p:nvPr/>
           </p:nvSpPr>
@@ -11724,7 +11786,7 @@
         </p:sp>
         <p:sp>
           <p:nvSpPr>
-            <p:cNvPr id="47" name="TextBox 47"/>
+            <p:cNvPr id="49" name="TextBox 49"/>
             <p:cNvSpPr txBox="1"/>
             <p:nvPr/>
           </p:nvSpPr>

</xml_diff>